<commit_message>
docs(presentations): add illustrations to the "What's New" deck
Embed five generated visuals into the 2026-06-22 continuation deck,
each processed to knock out its near-white background so it blends onto
the Tricentis-palette slides:

- slide 1  full-bleed converging-lines -> gate hero (lower-third scrim)
- slide 4  worktree-isolation diagram (left) + callouts (right)
- slide 6  gate emblem anchoring the "gate certifies" tagline banner
- slide 7  four feature icons, one per card (icon grid split 2x2)
- slide 9  scales-of-justice balance beside the proposer/certifier table

Assets live in docs/presentations/assets/whats-new/; the deck is
regenerated by build-whats-new-deck.py. Kept as a separate commit on top
of the imageless baseline (790078c) so the visuals can be reverted
wholesale if they don't land.

Co-Authored-By: Claude Opus 4.8 <noreply@anthropic.com>
</commit_message>
<xml_diff>
--- a/docs/presentations/guardrails-whats-new-2026-06-22.pptx
+++ b/docs/presentations/guardrails-whats-new-2026-06-22.pptx
@@ -4191,16 +4191,315 @@
           </a:p>
         </p:txBody>
       </p:sp>
-      <p:sp>
-        <p:nvSpPr>
-          <p:cNvPr id="3" name="Rectangle 2"/>
+      <p:pic>
+        <p:nvPicPr>
+          <p:cNvPr id="3" name="Picture 2" descr="image.png"/>
+          <p:cNvPicPr>
+            <a:picLocks noChangeAspect="1"/>
+          </p:cNvPicPr>
+          <p:nvPr/>
+        </p:nvPicPr>
+        <p:blipFill>
+          <a:blip r:embed="rId2"/>
+          <a:stretch>
+            <a:fillRect/>
+          </a:stretch>
+        </p:blipFill>
+        <p:spPr>
+          <a:xfrm>
+            <a:off x="-4564045" y="0"/>
+            <a:ext cx="18272091" cy="5143500"/>
+          </a:xfrm>
+          <a:prstGeom prst="rect">
+            <a:avLst/>
+          </a:prstGeom>
+        </p:spPr>
+      </p:pic>
+      <p:sp>
+        <p:nvSpPr>
+          <p:cNvPr id="4" name="Rectangle 3"/>
           <p:cNvSpPr/>
           <p:nvPr/>
         </p:nvSpPr>
         <p:spPr>
           <a:xfrm>
-            <a:off x="0" y="0"/>
-            <a:ext cx="201168" cy="5143500"/>
+            <a:off x="0" y="3822191"/>
+            <a:ext cx="9144000" cy="1207008"/>
+          </a:xfrm>
+          <a:prstGeom prst="rect">
+            <a:avLst/>
+          </a:prstGeom>
+          <a:solidFill>
+            <a:srgbClr val="FFFFFF">
+              <a:alpha val="82000"/>
+            </a:srgbClr>
+          </a:solidFill>
+          <a:ln>
+            <a:noFill/>
+          </a:ln>
+          <a:effectLst/>
+        </p:spPr>
+        <p:style>
+          <a:lnRef idx="1">
+            <a:schemeClr val="accent1"/>
+          </a:lnRef>
+          <a:fillRef idx="3">
+            <a:schemeClr val="accent1"/>
+          </a:fillRef>
+          <a:effectRef idx="2">
+            <a:schemeClr val="accent1"/>
+          </a:effectRef>
+          <a:fontRef idx="minor">
+            <a:schemeClr val="lt1"/>
+          </a:fontRef>
+        </p:style>
+        <p:txBody>
+          <a:bodyPr rtlCol="0" anchor="ctr"/>
+          <a:lstStyle/>
+          <a:p>
+            <a:pPr algn="ctr"/>
+          </a:p>
+        </p:txBody>
+      </p:sp>
+      <p:sp>
+        <p:nvSpPr>
+          <p:cNvPr id="5" name="Rounded Rectangle 4"/>
+          <p:cNvSpPr/>
+          <p:nvPr/>
+        </p:nvSpPr>
+        <p:spPr>
+          <a:xfrm>
+            <a:off x="502920" y="365760"/>
+            <a:ext cx="3611880" cy="347472"/>
+          </a:xfrm>
+          <a:prstGeom prst="roundRect">
+            <a:avLst>
+              <a:gd name="adj" fmla="val 50000"/>
+            </a:avLst>
+          </a:prstGeom>
+          <a:solidFill>
+            <a:srgbClr val="F36F21"/>
+          </a:solidFill>
+          <a:ln>
+            <a:noFill/>
+          </a:ln>
+          <a:effectLst/>
+        </p:spPr>
+        <p:style>
+          <a:lnRef idx="1">
+            <a:schemeClr val="accent1"/>
+          </a:lnRef>
+          <a:fillRef idx="3">
+            <a:schemeClr val="accent1"/>
+          </a:fillRef>
+          <a:effectRef idx="2">
+            <a:schemeClr val="accent1"/>
+          </a:effectRef>
+          <a:fontRef idx="minor">
+            <a:schemeClr val="lt1"/>
+          </a:fontRef>
+        </p:style>
+        <p:txBody>
+          <a:bodyPr rtlCol="0" anchor="ctr" wrap="square" lIns="54864" rIns="54864" tIns="27432" bIns="27432"/>
+          <a:lstStyle/>
+          <a:p>
+            <a:pPr algn="ctr"/>
+            <a:r>
+              <a:rPr sz="1100" b="1" i="0">
+                <a:solidFill>
+                  <a:srgbClr val="FFFFFF"/>
+                </a:solidFill>
+                <a:latin typeface="Arial"/>
+              </a:rPr>
+              <a:t>WHAT’S NEW  ·  SINCE THE LUNCH &amp; LEARN</a:t>
+            </a:r>
+          </a:p>
+        </p:txBody>
+      </p:sp>
+      <p:sp>
+        <p:nvSpPr>
+          <p:cNvPr id="6" name="TextBox 5"/>
+          <p:cNvSpPr txBox="1"/>
+          <p:nvPr/>
+        </p:nvSpPr>
+        <p:spPr>
+          <a:xfrm>
+            <a:off x="502920" y="786384"/>
+            <a:ext cx="6675120" cy="640080"/>
+          </a:xfrm>
+          <a:prstGeom prst="rect">
+            <a:avLst/>
+          </a:prstGeom>
+          <a:noFill/>
+        </p:spPr>
+        <p:txBody>
+          <a:bodyPr wrap="square" anchor="t" lIns="54864" rIns="54864" tIns="27432" bIns="27432">
+            <a:spAutoFit/>
+          </a:bodyPr>
+          <a:lstStyle/>
+          <a:p>
+            <a:pPr algn="l"/>
+            <a:r>
+              <a:rPr sz="3800" b="1" i="0">
+                <a:solidFill>
+                  <a:srgbClr val="01499B"/>
+                </a:solidFill>
+                <a:latin typeface="Arial"/>
+              </a:rPr>
+              <a:t>Guardrails: What’s New</a:t>
+            </a:r>
+          </a:p>
+        </p:txBody>
+      </p:sp>
+      <p:sp>
+        <p:nvSpPr>
+          <p:cNvPr id="7" name="Rectangle 6"/>
+          <p:cNvSpPr/>
+          <p:nvPr/>
+        </p:nvSpPr>
+        <p:spPr>
+          <a:xfrm>
+            <a:off x="502920" y="3931920"/>
+            <a:ext cx="1280160" cy="36576"/>
+          </a:xfrm>
+          <a:prstGeom prst="rect">
+            <a:avLst/>
+          </a:prstGeom>
+          <a:solidFill>
+            <a:srgbClr val="F36F21"/>
+          </a:solidFill>
+          <a:ln>
+            <a:noFill/>
+          </a:ln>
+          <a:effectLst/>
+        </p:spPr>
+        <p:style>
+          <a:lnRef idx="1">
+            <a:schemeClr val="accent1"/>
+          </a:lnRef>
+          <a:fillRef idx="3">
+            <a:schemeClr val="accent1"/>
+          </a:fillRef>
+          <a:effectRef idx="2">
+            <a:schemeClr val="accent1"/>
+          </a:effectRef>
+          <a:fontRef idx="minor">
+            <a:schemeClr val="lt1"/>
+          </a:fontRef>
+        </p:style>
+        <p:txBody>
+          <a:bodyPr rtlCol="0" anchor="ctr"/>
+          <a:lstStyle/>
+          <a:p>
+            <a:pPr algn="ctr"/>
+          </a:p>
+        </p:txBody>
+      </p:sp>
+      <p:sp>
+        <p:nvSpPr>
+          <p:cNvPr id="8" name="TextBox 7"/>
+          <p:cNvSpPr txBox="1"/>
+          <p:nvPr/>
+        </p:nvSpPr>
+        <p:spPr>
+          <a:xfrm>
+            <a:off x="502920" y="4041648"/>
+            <a:ext cx="8229600" cy="411480"/>
+          </a:xfrm>
+          <a:prstGeom prst="rect">
+            <a:avLst/>
+          </a:prstGeom>
+          <a:noFill/>
+        </p:spPr>
+        <p:txBody>
+          <a:bodyPr wrap="square" anchor="t" lIns="54864" rIns="54864" tIns="27432" bIns="27432">
+            <a:spAutoFit/>
+          </a:bodyPr>
+          <a:lstStyle/>
+          <a:p>
+            <a:pPr algn="l"/>
+            <a:r>
+              <a:rPr sz="1800" b="1" i="0">
+                <a:solidFill>
+                  <a:srgbClr val="374151"/>
+                </a:solidFill>
+                <a:latin typeface="Arial"/>
+              </a:rPr>
+              <a:t>From one verified task to a whole team of them — running at once</a:t>
+            </a:r>
+          </a:p>
+        </p:txBody>
+      </p:sp>
+      <p:sp>
+        <p:nvSpPr>
+          <p:cNvPr id="9" name="TextBox 8"/>
+          <p:cNvSpPr txBox="1"/>
+          <p:nvPr/>
+        </p:nvSpPr>
+        <p:spPr>
+          <a:xfrm>
+            <a:off x="502920" y="4498848"/>
+            <a:ext cx="8229600" cy="594360"/>
+          </a:xfrm>
+          <a:prstGeom prst="rect">
+            <a:avLst/>
+          </a:prstGeom>
+          <a:noFill/>
+        </p:spPr>
+        <p:txBody>
+          <a:bodyPr wrap="square" anchor="t" lIns="54864" rIns="54864" tIns="27432" bIns="27432">
+            <a:spAutoFit/>
+          </a:bodyPr>
+          <a:lstStyle/>
+          <a:p>
+            <a:pPr algn="l">
+              <a:spcAft>
+                <a:spcPts val="200"/>
+              </a:spcAft>
+            </a:pPr>
+            <a:r>
+              <a:rPr sz="1400" b="1" i="0">
+                <a:solidFill>
+                  <a:srgbClr val="1F2937"/>
+                </a:solidFill>
+                <a:latin typeface="Arial"/>
+              </a:rPr>
+              <a:t>David Maltby</a:t>
+            </a:r>
+            <a:r>
+              <a:rPr sz="1200" b="0" i="0">
+                <a:solidFill>
+                  <a:srgbClr val="6B7280"/>
+                </a:solidFill>
+                <a:latin typeface="Arial"/>
+              </a:rPr>
+              <a:t>    ·    A few weeks on from the Lunch &amp; Learn  ·  June 2026</a:t>
+            </a:r>
+          </a:p>
+          <a:p>
+            <a:pPr algn="l"/>
+            <a:r>
+              <a:rPr sz="1050" b="0" i="0">
+                <a:solidFill>
+                  <a:srgbClr val="6B7280"/>
+                </a:solidFill>
+                <a:latin typeface="Courier New"/>
+              </a:rPr>
+              <a:t>github.com/Servant-Software-LLC/Guardrails  ·  ServantSoftware.Guardrails  v1.0.0-preview.19</a:t>
+            </a:r>
+          </a:p>
+        </p:txBody>
+      </p:sp>
+      <p:sp>
+        <p:nvSpPr>
+          <p:cNvPr id="10" name="Rectangle 9"/>
+          <p:cNvSpPr/>
+          <p:nvPr/>
+        </p:nvSpPr>
+        <p:spPr>
+          <a:xfrm>
+            <a:off x="0" y="5029200"/>
+            <a:ext cx="9144000" cy="114300"/>
           </a:xfrm>
           <a:prstGeom prst="rect">
             <a:avLst/>
@@ -4237,113 +4536,14 @@
       </p:sp>
       <p:sp>
         <p:nvSpPr>
-          <p:cNvPr id="4" name="Rectangle 3"/>
-          <p:cNvSpPr/>
-          <p:nvPr/>
-        </p:nvSpPr>
-        <p:spPr>
-          <a:xfrm>
-            <a:off x="0" y="0"/>
-            <a:ext cx="201168" cy="1737360"/>
-          </a:xfrm>
-          <a:prstGeom prst="rect">
-            <a:avLst/>
-          </a:prstGeom>
-          <a:solidFill>
-            <a:srgbClr val="F36F21"/>
-          </a:solidFill>
-          <a:ln>
-            <a:noFill/>
-          </a:ln>
-          <a:effectLst/>
-        </p:spPr>
-        <p:style>
-          <a:lnRef idx="1">
-            <a:schemeClr val="accent1"/>
-          </a:lnRef>
-          <a:fillRef idx="3">
-            <a:schemeClr val="accent1"/>
-          </a:fillRef>
-          <a:effectRef idx="2">
-            <a:schemeClr val="accent1"/>
-          </a:effectRef>
-          <a:fontRef idx="minor">
-            <a:schemeClr val="lt1"/>
-          </a:fontRef>
-        </p:style>
-        <p:txBody>
-          <a:bodyPr rtlCol="0" anchor="ctr"/>
-          <a:lstStyle/>
-          <a:p>
-            <a:pPr algn="ctr"/>
-          </a:p>
-        </p:txBody>
-      </p:sp>
-      <p:sp>
-        <p:nvSpPr>
-          <p:cNvPr id="5" name="Rounded Rectangle 4"/>
-          <p:cNvSpPr/>
-          <p:nvPr/>
-        </p:nvSpPr>
-        <p:spPr>
-          <a:xfrm>
-            <a:off x="694944" y="749808"/>
-            <a:ext cx="3657600" cy="365760"/>
-          </a:xfrm>
-          <a:prstGeom prst="roundRect">
-            <a:avLst>
-              <a:gd name="adj" fmla="val 50000"/>
-            </a:avLst>
-          </a:prstGeom>
-          <a:solidFill>
-            <a:srgbClr val="F36F21"/>
-          </a:solidFill>
-          <a:ln>
-            <a:noFill/>
-          </a:ln>
-          <a:effectLst/>
-        </p:spPr>
-        <p:style>
-          <a:lnRef idx="1">
-            <a:schemeClr val="accent1"/>
-          </a:lnRef>
-          <a:fillRef idx="3">
-            <a:schemeClr val="accent1"/>
-          </a:fillRef>
-          <a:effectRef idx="2">
-            <a:schemeClr val="accent1"/>
-          </a:effectRef>
-          <a:fontRef idx="minor">
-            <a:schemeClr val="lt1"/>
-          </a:fontRef>
-        </p:style>
-        <p:txBody>
-          <a:bodyPr rtlCol="0" anchor="ctr" wrap="square" lIns="54864" rIns="54864" tIns="27432" bIns="27432"/>
-          <a:lstStyle/>
-          <a:p>
-            <a:pPr algn="ctr"/>
-            <a:r>
-              <a:rPr sz="1100" b="1" i="0">
-                <a:solidFill>
-                  <a:srgbClr val="FFFFFF"/>
-                </a:solidFill>
-                <a:latin typeface="Arial"/>
-              </a:rPr>
-              <a:t>WHAT’S NEW  ·  SINCE THE LUNCH &amp; LEARN</a:t>
-            </a:r>
-          </a:p>
-        </p:txBody>
-      </p:sp>
-      <p:sp>
-        <p:nvSpPr>
-          <p:cNvPr id="6" name="TextBox 5"/>
+          <p:cNvPr id="11" name="TextBox 10"/>
           <p:cNvSpPr txBox="1"/>
           <p:nvPr/>
         </p:nvSpPr>
         <p:spPr>
           <a:xfrm>
-            <a:off x="676656" y="1298448"/>
-            <a:ext cx="8138160" cy="960120"/>
+            <a:off x="448056" y="4992624"/>
+            <a:ext cx="4572000" cy="182880"/>
           </a:xfrm>
           <a:prstGeom prst="rect">
             <a:avLst/>
@@ -4358,293 +4558,20 @@
           <a:p>
             <a:pPr algn="l"/>
             <a:r>
-              <a:rPr sz="5000" b="1" i="0">
-                <a:solidFill>
-                  <a:srgbClr val="01499B"/>
-                </a:solidFill>
-                <a:latin typeface="Arial"/>
-              </a:rPr>
-              <a:t>Guardrails: What’s New</a:t>
-            </a:r>
-          </a:p>
-        </p:txBody>
-      </p:sp>
-      <p:sp>
-        <p:nvSpPr>
-          <p:cNvPr id="7" name="TextBox 6"/>
-          <p:cNvSpPr txBox="1"/>
-          <p:nvPr/>
-        </p:nvSpPr>
-        <p:spPr>
-          <a:xfrm>
-            <a:off x="694944" y="2304288"/>
-            <a:ext cx="7955279" cy="731520"/>
-          </a:xfrm>
-          <a:prstGeom prst="rect">
-            <a:avLst/>
-          </a:prstGeom>
-          <a:noFill/>
-        </p:spPr>
-        <p:txBody>
-          <a:bodyPr wrap="square" anchor="t" lIns="54864" rIns="54864" tIns="27432" bIns="27432">
-            <a:spAutoFit/>
-          </a:bodyPr>
-          <a:lstStyle/>
-          <a:p>
-            <a:pPr algn="l">
-              <a:lnSpc>
-                <a:spcPct val="110000"/>
-              </a:lnSpc>
-            </a:pPr>
-            <a:r>
-              <a:rPr sz="2000" b="0" i="0">
-                <a:solidFill>
-                  <a:srgbClr val="374151"/>
-                </a:solidFill>
-                <a:latin typeface="Arial"/>
-              </a:rPr>
-              <a:t>From one verified task to a whole team of them — running at once</a:t>
-            </a:r>
-          </a:p>
-        </p:txBody>
-      </p:sp>
-      <p:sp>
-        <p:nvSpPr>
-          <p:cNvPr id="8" name="Rectangle 7"/>
-          <p:cNvSpPr/>
-          <p:nvPr/>
-        </p:nvSpPr>
-        <p:spPr>
-          <a:xfrm>
-            <a:off x="0" y="3657600"/>
-            <a:ext cx="9144000" cy="1485900"/>
-          </a:xfrm>
-          <a:prstGeom prst="rect">
-            <a:avLst/>
-          </a:prstGeom>
-          <a:solidFill>
-            <a:srgbClr val="EFF6FF"/>
-          </a:solidFill>
-          <a:ln>
-            <a:noFill/>
-          </a:ln>
-          <a:effectLst/>
-        </p:spPr>
-        <p:style>
-          <a:lnRef idx="1">
-            <a:schemeClr val="accent1"/>
-          </a:lnRef>
-          <a:fillRef idx="3">
-            <a:schemeClr val="accent1"/>
-          </a:fillRef>
-          <a:effectRef idx="2">
-            <a:schemeClr val="accent1"/>
-          </a:effectRef>
-          <a:fontRef idx="minor">
-            <a:schemeClr val="lt1"/>
-          </a:fontRef>
-        </p:style>
-        <p:txBody>
-          <a:bodyPr rtlCol="0" anchor="ctr"/>
-          <a:lstStyle/>
-          <a:p>
-            <a:pPr algn="ctr"/>
-          </a:p>
-        </p:txBody>
-      </p:sp>
-      <p:sp>
-        <p:nvSpPr>
-          <p:cNvPr id="9" name="Rectangle 8"/>
-          <p:cNvSpPr/>
-          <p:nvPr/>
-        </p:nvSpPr>
-        <p:spPr>
-          <a:xfrm>
-            <a:off x="694944" y="3822191"/>
-            <a:ext cx="1280160" cy="36576"/>
-          </a:xfrm>
-          <a:prstGeom prst="rect">
-            <a:avLst/>
-          </a:prstGeom>
-          <a:solidFill>
-            <a:srgbClr val="F36F21"/>
-          </a:solidFill>
-          <a:ln>
-            <a:noFill/>
-          </a:ln>
-          <a:effectLst/>
-        </p:spPr>
-        <p:style>
-          <a:lnRef idx="1">
-            <a:schemeClr val="accent1"/>
-          </a:lnRef>
-          <a:fillRef idx="3">
-            <a:schemeClr val="accent1"/>
-          </a:fillRef>
-          <a:effectRef idx="2">
-            <a:schemeClr val="accent1"/>
-          </a:effectRef>
-          <a:fontRef idx="minor">
-            <a:schemeClr val="lt1"/>
-          </a:fontRef>
-        </p:style>
-        <p:txBody>
-          <a:bodyPr rtlCol="0" anchor="ctr"/>
-          <a:lstStyle/>
-          <a:p>
-            <a:pPr algn="ctr"/>
-          </a:p>
-        </p:txBody>
-      </p:sp>
-      <p:sp>
-        <p:nvSpPr>
-          <p:cNvPr id="10" name="TextBox 9"/>
-          <p:cNvSpPr txBox="1"/>
-          <p:nvPr/>
-        </p:nvSpPr>
-        <p:spPr>
-          <a:xfrm>
-            <a:off x="694944" y="3950208"/>
-            <a:ext cx="7955279" cy="1005840"/>
-          </a:xfrm>
-          <a:prstGeom prst="rect">
-            <a:avLst/>
-          </a:prstGeom>
-          <a:noFill/>
-        </p:spPr>
-        <p:txBody>
-          <a:bodyPr wrap="square" anchor="t" lIns="54864" rIns="54864" tIns="27432" bIns="27432">
-            <a:spAutoFit/>
-          </a:bodyPr>
-          <a:lstStyle/>
-          <a:p>
-            <a:pPr algn="l">
-              <a:spcAft>
-                <a:spcPts val="300"/>
-              </a:spcAft>
-            </a:pPr>
-            <a:r>
-              <a:rPr sz="1600" b="1" i="0">
-                <a:solidFill>
-                  <a:srgbClr val="1F2937"/>
-                </a:solidFill>
-                <a:latin typeface="Arial"/>
-              </a:rPr>
-              <a:t>David Maltby</a:t>
-            </a:r>
-          </a:p>
-          <a:p>
-            <a:pPr algn="l">
-              <a:spcAft>
-                <a:spcPts val="300"/>
-              </a:spcAft>
-            </a:pPr>
-            <a:r>
-              <a:rPr sz="1300" b="0" i="0">
-                <a:solidFill>
-                  <a:srgbClr val="6B7280"/>
-                </a:solidFill>
-                <a:latin typeface="Arial"/>
-              </a:rPr>
-              <a:t>A few weeks on from the Lunch &amp; Learn   ·   June 2026</a:t>
-            </a:r>
-          </a:p>
-          <a:p>
-            <a:pPr algn="l"/>
-            <a:r>
-              <a:rPr sz="1100" b="0" i="0">
-                <a:solidFill>
-                  <a:srgbClr val="6B7280"/>
-                </a:solidFill>
-                <a:latin typeface="Courier New"/>
-              </a:rPr>
-              <a:t>github.com/Servant-Software-LLC/Guardrails   ·   ServantSoftware.Guardrails  v1.0.0-preview.19</a:t>
-            </a:r>
-          </a:p>
-        </p:txBody>
-      </p:sp>
-      <p:sp>
-        <p:nvSpPr>
-          <p:cNvPr id="11" name="Rectangle 10"/>
-          <p:cNvSpPr/>
-          <p:nvPr/>
-        </p:nvSpPr>
-        <p:spPr>
-          <a:xfrm>
-            <a:off x="0" y="5029200"/>
-            <a:ext cx="9144000" cy="114300"/>
-          </a:xfrm>
-          <a:prstGeom prst="rect">
-            <a:avLst/>
-          </a:prstGeom>
-          <a:solidFill>
-            <a:srgbClr val="01499B"/>
-          </a:solidFill>
-          <a:ln>
-            <a:noFill/>
-          </a:ln>
-          <a:effectLst/>
-        </p:spPr>
-        <p:style>
-          <a:lnRef idx="1">
-            <a:schemeClr val="accent1"/>
-          </a:lnRef>
-          <a:fillRef idx="3">
-            <a:schemeClr val="accent1"/>
-          </a:fillRef>
-          <a:effectRef idx="2">
-            <a:schemeClr val="accent1"/>
-          </a:effectRef>
-          <a:fontRef idx="minor">
-            <a:schemeClr val="lt1"/>
-          </a:fontRef>
-        </p:style>
-        <p:txBody>
-          <a:bodyPr rtlCol="0" anchor="ctr"/>
-          <a:lstStyle/>
-          <a:p>
-            <a:pPr algn="ctr"/>
+              <a:rPr sz="800" b="0" i="0">
+                <a:solidFill>
+                  <a:srgbClr val="94A3B8"/>
+                </a:solidFill>
+                <a:latin typeface="Arial"/>
+              </a:rPr>
+              <a:t>Guardrails — What's New</a:t>
+            </a:r>
           </a:p>
         </p:txBody>
       </p:sp>
       <p:sp>
         <p:nvSpPr>
           <p:cNvPr id="12" name="TextBox 11"/>
-          <p:cNvSpPr txBox="1"/>
-          <p:nvPr/>
-        </p:nvSpPr>
-        <p:spPr>
-          <a:xfrm>
-            <a:off x="448056" y="4992624"/>
-            <a:ext cx="4572000" cy="182880"/>
-          </a:xfrm>
-          <a:prstGeom prst="rect">
-            <a:avLst/>
-          </a:prstGeom>
-          <a:noFill/>
-        </p:spPr>
-        <p:txBody>
-          <a:bodyPr wrap="square" anchor="t" lIns="54864" rIns="54864" tIns="27432" bIns="27432">
-            <a:spAutoFit/>
-          </a:bodyPr>
-          <a:lstStyle/>
-          <a:p>
-            <a:pPr algn="l"/>
-            <a:r>
-              <a:rPr sz="800" b="0" i="0">
-                <a:solidFill>
-                  <a:srgbClr val="94A3B8"/>
-                </a:solidFill>
-                <a:latin typeface="Arial"/>
-              </a:rPr>
-              <a:t>Guardrails — What's New</a:t>
-            </a:r>
-          </a:p>
-        </p:txBody>
-      </p:sp>
-      <p:sp>
-        <p:nvSpPr>
-          <p:cNvPr id="13" name="TextBox 12"/>
           <p:cNvSpPr txBox="1"/>
           <p:nvPr/>
         </p:nvSpPr>
@@ -8188,8 +8115,8 @@
         </p:nvSpPr>
         <p:spPr>
           <a:xfrm>
-            <a:off x="448056" y="914400"/>
-            <a:ext cx="8257031" cy="310896"/>
+            <a:off x="448056" y="896112"/>
+            <a:ext cx="8257031" cy="329184"/>
           </a:xfrm>
           <a:prstGeom prst="rect">
             <a:avLst/>
@@ -8224,20 +8151,119 @@
           </a:p>
         </p:txBody>
       </p:sp>
-      <p:sp>
-        <p:nvSpPr>
-          <p:cNvPr id="6" name="Rounded Rectangle 5"/>
+      <p:pic>
+        <p:nvPicPr>
+          <p:cNvPr id="6" name="Picture 5" descr="image.png"/>
+          <p:cNvPicPr>
+            <a:picLocks noChangeAspect="1"/>
+          </p:cNvPicPr>
+          <p:nvPr/>
+        </p:nvPicPr>
+        <p:blipFill>
+          <a:blip r:embed="rId2"/>
+          <a:stretch>
+            <a:fillRect/>
+          </a:stretch>
+        </p:blipFill>
+        <p:spPr>
+          <a:xfrm>
+            <a:off x="892771" y="1371600"/>
+            <a:ext cx="2740737" cy="3200400"/>
+          </a:xfrm>
+          <a:prstGeom prst="rect">
+            <a:avLst/>
+          </a:prstGeom>
+        </p:spPr>
+      </p:pic>
+      <p:sp>
+        <p:nvSpPr>
+          <p:cNvPr id="7" name="TextBox 6"/>
+          <p:cNvSpPr txBox="1"/>
+          <p:nvPr/>
+        </p:nvSpPr>
+        <p:spPr>
+          <a:xfrm>
+            <a:off x="4370832" y="1417320"/>
+            <a:ext cx="4315968" cy="914400"/>
+          </a:xfrm>
+          <a:prstGeom prst="rect">
+            <a:avLst/>
+          </a:prstGeom>
+          <a:noFill/>
+        </p:spPr>
+        <p:txBody>
+          <a:bodyPr wrap="square" anchor="t" lIns="54864" rIns="54864" tIns="27432" bIns="27432">
+            <a:spAutoFit/>
+          </a:bodyPr>
+          <a:lstStyle/>
+          <a:p>
+            <a:pPr algn="l">
+              <a:lnSpc>
+                <a:spcPct val="112000"/>
+              </a:lnSpc>
+            </a:pPr>
+            <a:r>
+              <a:rPr sz="1250" b="0" i="0">
+                <a:solidFill>
+                  <a:srgbClr val="374151"/>
+                </a:solidFill>
+                <a:latin typeface="Arial"/>
+              </a:rPr>
+              <a:t>Each running task gets its own </a:t>
+            </a:r>
+            <a:r>
+              <a:rPr sz="1250" b="1" i="0">
+                <a:solidFill>
+                  <a:srgbClr val="01499B"/>
+                </a:solidFill>
+                <a:latin typeface="Arial"/>
+              </a:rPr>
+              <a:t>git worktree</a:t>
+            </a:r>
+            <a:r>
+              <a:rPr sz="1250" b="0" i="0">
+                <a:solidFill>
+                  <a:srgbClr val="374151"/>
+                </a:solidFill>
+                <a:latin typeface="Arial"/>
+              </a:rPr>
+              <a:t> — a separate working copy on its own branch. Each writes </a:t>
+            </a:r>
+            <a:r>
+              <a:rPr sz="1250" b="1" i="0">
+                <a:solidFill>
+                  <a:srgbClr val="01499B"/>
+                </a:solidFill>
+                <a:latin typeface="Arial"/>
+              </a:rPr>
+              <a:t>only its own tree</a:t>
+            </a:r>
+            <a:r>
+              <a:rPr sz="1250" b="0" i="0">
+                <a:solidFill>
+                  <a:srgbClr val="374151"/>
+                </a:solidFill>
+                <a:latin typeface="Arial"/>
+              </a:rPr>
+              <a:t>; the harness merges results back one at a time.</a:t>
+            </a:r>
+          </a:p>
+        </p:txBody>
+      </p:sp>
+      <p:sp>
+        <p:nvSpPr>
+          <p:cNvPr id="8" name="Rounded Rectangle 7"/>
           <p:cNvSpPr/>
           <p:nvPr/>
         </p:nvSpPr>
         <p:spPr>
           <a:xfrm>
-            <a:off x="2834640" y="1298448"/>
-            <a:ext cx="3474720" cy="512064"/>
+            <a:off x="4370832" y="2487168"/>
+            <a:ext cx="4334256" cy="914400"/>
           </a:xfrm>
           <a:prstGeom prst="roundRect">
             <a:avLst>
-              <a:gd name="adj" fmla="val 10000"/>
+              <a:gd name="adj" fmla="val 8000"/>
             </a:avLst>
           </a:prstGeom>
           <a:solidFill>
@@ -8263,531 +8289,16 @@
           </a:fontRef>
         </p:style>
         <p:txBody>
-          <a:bodyPr rtlCol="0" anchor="ctr" wrap="square" lIns="54864" rIns="54864" tIns="27432" bIns="27432"/>
-          <a:lstStyle/>
-          <a:p>
-            <a:pPr algn="ctr"/>
-            <a:r>
-              <a:rPr sz="1350" b="1" i="0">
-                <a:solidFill>
-                  <a:srgbClr val="FFFFFF"/>
-                </a:solidFill>
-                <a:latin typeface="Arial"/>
-              </a:rPr>
-              <a:t>plan branch</a:t>
-            </a:r>
-            <a:r>
-              <a:rPr sz="1050" b="0" i="0">
-                <a:solidFill>
-                  <a:srgbClr val="BFD3F0"/>
-                </a:solidFill>
-                <a:latin typeface="Arial"/>
-              </a:rPr>
-              <a:t>   · the durable, verified truth</a:t>
-            </a:r>
-          </a:p>
-        </p:txBody>
-      </p:sp>
-      <p:sp>
-        <p:nvSpPr>
-          <p:cNvPr id="7" name="Rounded Rectangle 6"/>
-          <p:cNvSpPr/>
-          <p:nvPr/>
-        </p:nvSpPr>
-        <p:spPr>
-          <a:xfrm>
-            <a:off x="868680" y="2212848"/>
-            <a:ext cx="1828800" cy="713232"/>
-          </a:xfrm>
-          <a:prstGeom prst="roundRect">
-            <a:avLst>
-              <a:gd name="adj" fmla="val 10000"/>
-            </a:avLst>
-          </a:prstGeom>
-          <a:solidFill>
-            <a:srgbClr val="EFF6FF"/>
-          </a:solidFill>
-          <a:ln w="15875">
-            <a:solidFill>
-              <a:srgbClr val="01499B"/>
-            </a:solidFill>
-          </a:ln>
-          <a:effectLst/>
-        </p:spPr>
-        <p:style>
-          <a:lnRef idx="1">
-            <a:schemeClr val="accent1"/>
-          </a:lnRef>
-          <a:fillRef idx="3">
-            <a:schemeClr val="accent1"/>
-          </a:fillRef>
-          <a:effectRef idx="2">
-            <a:schemeClr val="accent1"/>
-          </a:effectRef>
-          <a:fontRef idx="minor">
-            <a:schemeClr val="lt1"/>
-          </a:fontRef>
-        </p:style>
-        <p:txBody>
-          <a:bodyPr rtlCol="0" anchor="ctr" wrap="square" lIns="54864" rIns="54864" tIns="27432" bIns="27432"/>
-          <a:lstStyle/>
-          <a:p>
-            <a:pPr algn="ctr">
-              <a:spcAft>
-                <a:spcPts val="100"/>
-              </a:spcAft>
-            </a:pPr>
-            <a:r>
-              <a:rPr sz="1250" b="1" i="0">
-                <a:solidFill>
-                  <a:srgbClr val="01499B"/>
-                </a:solidFill>
-                <a:latin typeface="Courier New"/>
-              </a:rPr>
-              <a:t>worktree A</a:t>
-            </a:r>
-          </a:p>
-          <a:p>
-            <a:pPr algn="ctr"/>
-            <a:r>
-              <a:rPr sz="1050" b="0" i="0">
-                <a:solidFill>
-                  <a:srgbClr val="374151"/>
-                </a:solidFill>
-                <a:latin typeface="Arial"/>
-              </a:rPr>
-              <a:t>task 01</a:t>
-            </a:r>
-          </a:p>
-        </p:txBody>
-      </p:sp>
-      <p:sp>
-        <p:nvSpPr>
-          <p:cNvPr id="8" name="TextBox 7"/>
-          <p:cNvSpPr txBox="1"/>
-          <p:nvPr/>
-        </p:nvSpPr>
-        <p:spPr>
-          <a:xfrm>
-            <a:off x="868680" y="1810512"/>
-            <a:ext cx="1828800" cy="384048"/>
-          </a:xfrm>
-          <a:prstGeom prst="rect">
-            <a:avLst/>
-          </a:prstGeom>
-          <a:noFill/>
-        </p:spPr>
-        <p:txBody>
-          <a:bodyPr wrap="square" anchor="ctr" lIns="54864" rIns="54864" tIns="27432" bIns="27432">
-            <a:spAutoFit/>
-          </a:bodyPr>
-          <a:lstStyle/>
-          <a:p>
-            <a:pPr algn="ctr"/>
-            <a:r>
-              <a:rPr sz="1800" b="1" i="0">
-                <a:solidFill>
-                  <a:srgbClr val="94A3B8"/>
-                </a:solidFill>
-                <a:latin typeface="Arial"/>
-              </a:rPr>
-              <a:t>↓</a:t>
-            </a:r>
-          </a:p>
-        </p:txBody>
-      </p:sp>
-      <p:sp>
-        <p:nvSpPr>
-          <p:cNvPr id="9" name="Rounded Rectangle 8"/>
-          <p:cNvSpPr/>
-          <p:nvPr/>
-        </p:nvSpPr>
-        <p:spPr>
-          <a:xfrm>
-            <a:off x="3657600" y="2212848"/>
-            <a:ext cx="1828800" cy="713232"/>
-          </a:xfrm>
-          <a:prstGeom prst="roundRect">
-            <a:avLst>
-              <a:gd name="adj" fmla="val 10000"/>
-            </a:avLst>
-          </a:prstGeom>
-          <a:solidFill>
-            <a:srgbClr val="EFF6FF"/>
-          </a:solidFill>
-          <a:ln w="15875">
-            <a:solidFill>
-              <a:srgbClr val="01499B"/>
-            </a:solidFill>
-          </a:ln>
-          <a:effectLst/>
-        </p:spPr>
-        <p:style>
-          <a:lnRef idx="1">
-            <a:schemeClr val="accent1"/>
-          </a:lnRef>
-          <a:fillRef idx="3">
-            <a:schemeClr val="accent1"/>
-          </a:fillRef>
-          <a:effectRef idx="2">
-            <a:schemeClr val="accent1"/>
-          </a:effectRef>
-          <a:fontRef idx="minor">
-            <a:schemeClr val="lt1"/>
-          </a:fontRef>
-        </p:style>
-        <p:txBody>
-          <a:bodyPr rtlCol="0" anchor="ctr" wrap="square" lIns="54864" rIns="54864" tIns="27432" bIns="27432"/>
-          <a:lstStyle/>
-          <a:p>
-            <a:pPr algn="ctr">
-              <a:spcAft>
-                <a:spcPts val="100"/>
-              </a:spcAft>
-            </a:pPr>
-            <a:r>
-              <a:rPr sz="1250" b="1" i="0">
-                <a:solidFill>
-                  <a:srgbClr val="01499B"/>
-                </a:solidFill>
-                <a:latin typeface="Courier New"/>
-              </a:rPr>
-              <a:t>worktree B</a:t>
-            </a:r>
-          </a:p>
-          <a:p>
-            <a:pPr algn="ctr"/>
-            <a:r>
-              <a:rPr sz="1050" b="0" i="0">
-                <a:solidFill>
-                  <a:srgbClr val="374151"/>
-                </a:solidFill>
-                <a:latin typeface="Arial"/>
-              </a:rPr>
-              <a:t>task 02</a:t>
-            </a:r>
-          </a:p>
-        </p:txBody>
-      </p:sp>
-      <p:sp>
-        <p:nvSpPr>
-          <p:cNvPr id="10" name="TextBox 9"/>
-          <p:cNvSpPr txBox="1"/>
-          <p:nvPr/>
-        </p:nvSpPr>
-        <p:spPr>
-          <a:xfrm>
-            <a:off x="3657600" y="1810512"/>
-            <a:ext cx="1828800" cy="384048"/>
-          </a:xfrm>
-          <a:prstGeom prst="rect">
-            <a:avLst/>
-          </a:prstGeom>
-          <a:noFill/>
-        </p:spPr>
-        <p:txBody>
-          <a:bodyPr wrap="square" anchor="ctr" lIns="54864" rIns="54864" tIns="27432" bIns="27432">
-            <a:spAutoFit/>
-          </a:bodyPr>
-          <a:lstStyle/>
-          <a:p>
-            <a:pPr algn="ctr"/>
-            <a:r>
-              <a:rPr sz="1800" b="1" i="0">
-                <a:solidFill>
-                  <a:srgbClr val="94A3B8"/>
-                </a:solidFill>
-                <a:latin typeface="Arial"/>
-              </a:rPr>
-              <a:t>↓</a:t>
-            </a:r>
-          </a:p>
-        </p:txBody>
-      </p:sp>
-      <p:sp>
-        <p:nvSpPr>
-          <p:cNvPr id="11" name="Rounded Rectangle 10"/>
-          <p:cNvSpPr/>
-          <p:nvPr/>
-        </p:nvSpPr>
-        <p:spPr>
-          <a:xfrm>
-            <a:off x="6446520" y="2212848"/>
-            <a:ext cx="1828800" cy="713232"/>
-          </a:xfrm>
-          <a:prstGeom prst="roundRect">
-            <a:avLst>
-              <a:gd name="adj" fmla="val 10000"/>
-            </a:avLst>
-          </a:prstGeom>
-          <a:solidFill>
-            <a:srgbClr val="EFF6FF"/>
-          </a:solidFill>
-          <a:ln w="15875">
-            <a:solidFill>
-              <a:srgbClr val="01499B"/>
-            </a:solidFill>
-          </a:ln>
-          <a:effectLst/>
-        </p:spPr>
-        <p:style>
-          <a:lnRef idx="1">
-            <a:schemeClr val="accent1"/>
-          </a:lnRef>
-          <a:fillRef idx="3">
-            <a:schemeClr val="accent1"/>
-          </a:fillRef>
-          <a:effectRef idx="2">
-            <a:schemeClr val="accent1"/>
-          </a:effectRef>
-          <a:fontRef idx="minor">
-            <a:schemeClr val="lt1"/>
-          </a:fontRef>
-        </p:style>
-        <p:txBody>
-          <a:bodyPr rtlCol="0" anchor="ctr" wrap="square" lIns="54864" rIns="54864" tIns="27432" bIns="27432"/>
-          <a:lstStyle/>
-          <a:p>
-            <a:pPr algn="ctr">
-              <a:spcAft>
-                <a:spcPts val="100"/>
-              </a:spcAft>
-            </a:pPr>
-            <a:r>
-              <a:rPr sz="1250" b="1" i="0">
-                <a:solidFill>
-                  <a:srgbClr val="01499B"/>
-                </a:solidFill>
-                <a:latin typeface="Courier New"/>
-              </a:rPr>
-              <a:t>worktree C</a:t>
-            </a:r>
-          </a:p>
-          <a:p>
-            <a:pPr algn="ctr"/>
-            <a:r>
-              <a:rPr sz="1050" b="0" i="0">
-                <a:solidFill>
-                  <a:srgbClr val="374151"/>
-                </a:solidFill>
-                <a:latin typeface="Arial"/>
-              </a:rPr>
-              <a:t>task 03</a:t>
-            </a:r>
-          </a:p>
-        </p:txBody>
-      </p:sp>
-      <p:sp>
-        <p:nvSpPr>
-          <p:cNvPr id="12" name="TextBox 11"/>
-          <p:cNvSpPr txBox="1"/>
-          <p:nvPr/>
-        </p:nvSpPr>
-        <p:spPr>
-          <a:xfrm>
-            <a:off x="6446520" y="1810512"/>
-            <a:ext cx="1828800" cy="384048"/>
-          </a:xfrm>
-          <a:prstGeom prst="rect">
-            <a:avLst/>
-          </a:prstGeom>
-          <a:noFill/>
-        </p:spPr>
-        <p:txBody>
-          <a:bodyPr wrap="square" anchor="ctr" lIns="54864" rIns="54864" tIns="27432" bIns="27432">
-            <a:spAutoFit/>
-          </a:bodyPr>
-          <a:lstStyle/>
-          <a:p>
-            <a:pPr algn="ctr"/>
-            <a:r>
-              <a:rPr sz="1800" b="1" i="0">
-                <a:solidFill>
-                  <a:srgbClr val="94A3B8"/>
-                </a:solidFill>
-                <a:latin typeface="Arial"/>
-              </a:rPr>
-              <a:t>↓</a:t>
-            </a:r>
-          </a:p>
-        </p:txBody>
-      </p:sp>
-      <p:sp>
-        <p:nvSpPr>
-          <p:cNvPr id="13" name="TextBox 12"/>
-          <p:cNvSpPr txBox="1"/>
-          <p:nvPr/>
-        </p:nvSpPr>
-        <p:spPr>
-          <a:xfrm>
-            <a:off x="868680" y="2907792"/>
-            <a:ext cx="7406640" cy="274320"/>
-          </a:xfrm>
-          <a:prstGeom prst="rect">
-            <a:avLst/>
-          </a:prstGeom>
-          <a:noFill/>
-        </p:spPr>
-        <p:txBody>
-          <a:bodyPr wrap="square" anchor="t" lIns="54864" rIns="54864" tIns="27432" bIns="27432">
-            <a:spAutoFit/>
-          </a:bodyPr>
-          <a:lstStyle/>
-          <a:p>
-            <a:pPr algn="ctr"/>
-            <a:r>
-              <a:rPr sz="1150" b="0" i="1">
-                <a:solidFill>
-                  <a:srgbClr val="6B7280"/>
-                </a:solidFill>
-                <a:latin typeface="Arial"/>
-              </a:rPr>
-              <a:t>each writes ONLY its own tree</a:t>
-            </a:r>
-          </a:p>
-        </p:txBody>
-      </p:sp>
-      <p:sp>
-        <p:nvSpPr>
-          <p:cNvPr id="14" name="TextBox 13"/>
-          <p:cNvSpPr txBox="1"/>
-          <p:nvPr/>
-        </p:nvSpPr>
-        <p:spPr>
-          <a:xfrm>
-            <a:off x="2834640" y="3127248"/>
-            <a:ext cx="3474720" cy="310896"/>
-          </a:xfrm>
-          <a:prstGeom prst="rect">
-            <a:avLst/>
-          </a:prstGeom>
-          <a:noFill/>
-        </p:spPr>
-        <p:txBody>
-          <a:bodyPr wrap="square" anchor="ctr" lIns="54864" rIns="54864" tIns="27432" bIns="27432">
-            <a:spAutoFit/>
-          </a:bodyPr>
-          <a:lstStyle/>
-          <a:p>
-            <a:pPr algn="ctr"/>
-            <a:r>
-              <a:rPr sz="1800" b="1" i="0">
-                <a:solidFill>
-                  <a:srgbClr val="94A3B8"/>
-                </a:solidFill>
-                <a:latin typeface="Arial"/>
-              </a:rPr>
-              <a:t>↓</a:t>
-            </a:r>
-          </a:p>
-        </p:txBody>
-      </p:sp>
-      <p:sp>
-        <p:nvSpPr>
-          <p:cNvPr id="15" name="Rounded Rectangle 14"/>
-          <p:cNvSpPr/>
-          <p:nvPr/>
-        </p:nvSpPr>
-        <p:spPr>
-          <a:xfrm>
-            <a:off x="2377440" y="3419856"/>
-            <a:ext cx="4389120" cy="420624"/>
-          </a:xfrm>
-          <a:prstGeom prst="roundRect">
-            <a:avLst>
-              <a:gd name="adj" fmla="val 12000"/>
-            </a:avLst>
-          </a:prstGeom>
-          <a:solidFill>
-            <a:srgbClr val="F8FAFC"/>
-          </a:solidFill>
-          <a:ln w="12700">
-            <a:solidFill>
-              <a:srgbClr val="D1D5DB"/>
-            </a:solidFill>
-          </a:ln>
-          <a:effectLst/>
-        </p:spPr>
-        <p:style>
-          <a:lnRef idx="1">
-            <a:schemeClr val="accent1"/>
-          </a:lnRef>
-          <a:fillRef idx="3">
-            <a:schemeClr val="accent1"/>
-          </a:fillRef>
-          <a:effectRef idx="2">
-            <a:schemeClr val="accent1"/>
-          </a:effectRef>
-          <a:fontRef idx="minor">
-            <a:schemeClr val="lt1"/>
-          </a:fontRef>
-        </p:style>
-        <p:txBody>
-          <a:bodyPr rtlCol="0" anchor="ctr" wrap="square" lIns="54864" rIns="54864" tIns="27432" bIns="27432"/>
-          <a:lstStyle/>
-          <a:p>
-            <a:pPr algn="ctr"/>
-            <a:r>
-              <a:rPr sz="1150" b="1" i="0">
-                <a:solidFill>
-                  <a:srgbClr val="374151"/>
-                </a:solidFill>
-                <a:latin typeface="Arial"/>
-              </a:rPr>
-              <a:t>harness merges each result back — one at a time</a:t>
-            </a:r>
-          </a:p>
-        </p:txBody>
-      </p:sp>
-      <p:sp>
-        <p:nvSpPr>
-          <p:cNvPr id="16" name="Rounded Rectangle 15"/>
-          <p:cNvSpPr/>
-          <p:nvPr/>
-        </p:nvSpPr>
-        <p:spPr>
-          <a:xfrm>
-            <a:off x="448056" y="3968496"/>
-            <a:ext cx="5212080" cy="749808"/>
-          </a:xfrm>
-          <a:prstGeom prst="roundRect">
-            <a:avLst>
-              <a:gd name="adj" fmla="val 8000"/>
-            </a:avLst>
-          </a:prstGeom>
-          <a:solidFill>
-            <a:srgbClr val="01499B"/>
-          </a:solidFill>
-          <a:ln>
-            <a:noFill/>
-          </a:ln>
-          <a:effectLst/>
-        </p:spPr>
-        <p:style>
-          <a:lnRef idx="1">
-            <a:schemeClr val="accent1"/>
-          </a:lnRef>
-          <a:fillRef idx="3">
-            <a:schemeClr val="accent1"/>
-          </a:fillRef>
-          <a:effectRef idx="2">
-            <a:schemeClr val="accent1"/>
-          </a:effectRef>
-          <a:fontRef idx="minor">
-            <a:schemeClr val="lt1"/>
-          </a:fontRef>
-        </p:style>
-        <p:txBody>
-          <a:bodyPr rtlCol="0" anchor="ctr" wrap="square" lIns="182880" rIns="146304" tIns="27432" bIns="27432"/>
+          <a:bodyPr rtlCol="0" anchor="ctr" wrap="square" lIns="201168" rIns="164592" tIns="27432" bIns="27432"/>
           <a:lstStyle/>
           <a:p>
             <a:pPr algn="l">
               <a:lnSpc>
-                <a:spcPct val="105000"/>
+                <a:spcPct val="108000"/>
               </a:lnSpc>
             </a:pPr>
             <a:r>
-              <a:rPr sz="1200" b="0" i="0">
+              <a:rPr sz="1250" b="0" i="0">
                 <a:solidFill>
                   <a:srgbClr val="FFFFFF"/>
                 </a:solidFill>
@@ -8796,7 +8307,7 @@
               <a:t>“Agent B clobbered agent A’s edits” is </a:t>
             </a:r>
             <a:r>
-              <a:rPr sz="1200" b="1" i="0">
+              <a:rPr sz="1250" b="1" i="0">
                 <a:solidFill>
                   <a:srgbClr val="FFC9A3"/>
                 </a:solidFill>
@@ -8805,7 +8316,7 @@
               <a:t>structurally impossible</a:t>
             </a:r>
             <a:r>
-              <a:rPr sz="1200" b="0" i="0">
+              <a:rPr sz="1250" b="0" i="0">
                 <a:solidFill>
                   <a:srgbClr val="FFFFFF"/>
                 </a:solidFill>
@@ -8818,14 +8329,14 @@
       </p:sp>
       <p:sp>
         <p:nvSpPr>
-          <p:cNvPr id="17" name="Rectangle 16"/>
+          <p:cNvPr id="9" name="Rectangle 8"/>
           <p:cNvSpPr/>
           <p:nvPr/>
         </p:nvSpPr>
         <p:spPr>
           <a:xfrm>
-            <a:off x="448056" y="3968496"/>
-            <a:ext cx="91440" cy="749808"/>
+            <a:off x="4370832" y="2487168"/>
+            <a:ext cx="91440" cy="914400"/>
           </a:xfrm>
           <a:prstGeom prst="rect">
             <a:avLst/>
@@ -8862,14 +8373,14 @@
       </p:sp>
       <p:sp>
         <p:nvSpPr>
-          <p:cNvPr id="18" name="Rounded Rectangle 17"/>
+          <p:cNvPr id="10" name="Rounded Rectangle 9"/>
           <p:cNvSpPr/>
           <p:nvPr/>
         </p:nvSpPr>
         <p:spPr>
           <a:xfrm>
-            <a:off x="5806440" y="3968496"/>
-            <a:ext cx="2898648" cy="749808"/>
+            <a:off x="4370832" y="3511296"/>
+            <a:ext cx="4334256" cy="868680"/>
           </a:xfrm>
           <a:prstGeom prst="roundRect">
             <a:avLst>
@@ -8901,16 +8412,16 @@
           </a:fontRef>
         </p:style>
         <p:txBody>
-          <a:bodyPr rtlCol="0" anchor="ctr" wrap="square" lIns="146304" rIns="146304" tIns="27432" bIns="27432"/>
+          <a:bodyPr rtlCol="0" anchor="ctr" wrap="square" lIns="182880" rIns="164592" tIns="27432" bIns="27432"/>
           <a:lstStyle/>
           <a:p>
             <a:pPr algn="l">
               <a:lnSpc>
-                <a:spcPct val="105000"/>
+                <a:spcPct val="108000"/>
               </a:lnSpc>
             </a:pPr>
             <a:r>
-              <a:rPr sz="1150" b="0" i="0">
+              <a:rPr sz="1250" b="0" i="0">
                 <a:solidFill>
                   <a:srgbClr val="374151"/>
                 </a:solidFill>
@@ -8919,7 +8430,7 @@
               <a:t>A linear chain </a:t>
             </a:r>
             <a:r>
-              <a:rPr sz="1150" b="1" i="0">
+              <a:rPr sz="1250" b="1" i="0">
                 <a:solidFill>
                   <a:srgbClr val="01499B"/>
                 </a:solidFill>
@@ -8928,20 +8439,20 @@
               <a:t>reuses one worktree</a:t>
             </a:r>
             <a:r>
-              <a:rPr sz="1150" b="0" i="0">
+              <a:rPr sz="1250" b="0" i="0">
                 <a:solidFill>
                   <a:srgbClr val="374151"/>
                 </a:solidFill>
                 <a:latin typeface="Arial"/>
               </a:rPr>
-              <a:t>, passed along — no paying for trees we don’t need.</a:t>
-            </a:r>
-          </a:p>
-        </p:txBody>
-      </p:sp>
-      <p:sp>
-        <p:nvSpPr>
-          <p:cNvPr id="19" name="Rectangle 18"/>
+              <a:t>, passed along — so we don’t pay for trees we don’t need.</a:t>
+            </a:r>
+          </a:p>
+        </p:txBody>
+      </p:sp>
+      <p:sp>
+        <p:nvSpPr>
+          <p:cNvPr id="11" name="Rectangle 10"/>
           <p:cNvSpPr/>
           <p:nvPr/>
         </p:nvSpPr>
@@ -8985,7 +8496,7 @@
       </p:sp>
       <p:sp>
         <p:nvSpPr>
-          <p:cNvPr id="20" name="TextBox 19"/>
+          <p:cNvPr id="12" name="TextBox 11"/>
           <p:cNvSpPr txBox="1"/>
           <p:nvPr/>
         </p:nvSpPr>
@@ -9020,7 +8531,7 @@
       </p:sp>
       <p:sp>
         <p:nvSpPr>
-          <p:cNvPr id="21" name="TextBox 20"/>
+          <p:cNvPr id="13" name="TextBox 12"/>
           <p:cNvSpPr txBox="1"/>
           <p:nvPr/>
         </p:nvSpPr>
@@ -10267,16 +9778,40 @@
           </a:p>
         </p:txBody>
       </p:sp>
-      <p:sp>
-        <p:nvSpPr>
-          <p:cNvPr id="11" name="Rounded Rectangle 10"/>
+      <p:pic>
+        <p:nvPicPr>
+          <p:cNvPr id="11" name="Picture 10" descr="image.png"/>
+          <p:cNvPicPr>
+            <a:picLocks noChangeAspect="1"/>
+          </p:cNvPicPr>
+          <p:nvPr/>
+        </p:nvPicPr>
+        <p:blipFill>
+          <a:blip r:embed="rId2"/>
+          <a:stretch>
+            <a:fillRect/>
+          </a:stretch>
+        </p:blipFill>
+        <p:spPr>
+          <a:xfrm>
+            <a:off x="481888" y="2944368"/>
+            <a:ext cx="1550822" cy="1207008"/>
+          </a:xfrm>
+          <a:prstGeom prst="rect">
+            <a:avLst/>
+          </a:prstGeom>
+        </p:spPr>
+      </p:pic>
+      <p:sp>
+        <p:nvSpPr>
+          <p:cNvPr id="12" name="Rounded Rectangle 11"/>
           <p:cNvSpPr/>
           <p:nvPr/>
         </p:nvSpPr>
         <p:spPr>
           <a:xfrm>
-            <a:off x="448056" y="2999232"/>
-            <a:ext cx="8257031" cy="1078992"/>
+            <a:off x="2194560" y="2999232"/>
+            <a:ext cx="6510528" cy="1078992"/>
           </a:xfrm>
           <a:prstGeom prst="roundRect">
             <a:avLst>
@@ -10315,13 +9850,13 @@
       </p:sp>
       <p:sp>
         <p:nvSpPr>
-          <p:cNvPr id="12" name="Rectangle 11"/>
+          <p:cNvPr id="13" name="Rectangle 12"/>
           <p:cNvSpPr/>
           <p:nvPr/>
         </p:nvSpPr>
         <p:spPr>
           <a:xfrm>
-            <a:off x="448056" y="2999232"/>
+            <a:off x="2194560" y="2999232"/>
             <a:ext cx="109728" cy="1078992"/>
           </a:xfrm>
           <a:prstGeom prst="rect">
@@ -10359,14 +9894,14 @@
       </p:sp>
       <p:sp>
         <p:nvSpPr>
-          <p:cNvPr id="13" name="Rectangle 12"/>
+          <p:cNvPr id="14" name="Rectangle 13"/>
           <p:cNvSpPr/>
           <p:nvPr/>
         </p:nvSpPr>
         <p:spPr>
           <a:xfrm>
-            <a:off x="448056" y="2999232"/>
-            <a:ext cx="8257031" cy="1078992"/>
+            <a:off x="2194560" y="2999232"/>
+            <a:ext cx="6510528" cy="1078992"/>
           </a:xfrm>
           <a:prstGeom prst="rect">
             <a:avLst/>
@@ -10429,7 +9964,7 @@
       </p:sp>
       <p:sp>
         <p:nvSpPr>
-          <p:cNvPr id="14" name="Rectangle 13"/>
+          <p:cNvPr id="15" name="Rectangle 14"/>
           <p:cNvSpPr/>
           <p:nvPr/>
         </p:nvSpPr>
@@ -10473,7 +10008,7 @@
       </p:sp>
       <p:sp>
         <p:nvSpPr>
-          <p:cNvPr id="15" name="TextBox 14"/>
+          <p:cNvPr id="16" name="TextBox 15"/>
           <p:cNvSpPr txBox="1"/>
           <p:nvPr/>
         </p:nvSpPr>
@@ -10508,7 +10043,7 @@
       </p:sp>
       <p:sp>
         <p:nvSpPr>
-          <p:cNvPr id="16" name="TextBox 15"/>
+          <p:cNvPr id="17" name="TextBox 16"/>
           <p:cNvSpPr txBox="1"/>
           <p:nvPr/>
         </p:nvSpPr>
@@ -10774,29 +10309,57 @@
           </a:p>
         </p:txBody>
       </p:sp>
-      <p:sp>
-        <p:nvSpPr>
-          <p:cNvPr id="7" name="TextBox 6"/>
-          <p:cNvSpPr txBox="1"/>
-          <p:nvPr/>
-        </p:nvSpPr>
-        <p:spPr>
-          <a:xfrm>
-            <a:off x="612647" y="1344168"/>
-            <a:ext cx="3712463" cy="274320"/>
+      <p:pic>
+        <p:nvPicPr>
+          <p:cNvPr id="7" name="Picture 6" descr="image.png"/>
+          <p:cNvPicPr>
+            <a:picLocks noChangeAspect="1"/>
+          </p:cNvPicPr>
+          <p:nvPr/>
+        </p:nvPicPr>
+        <p:blipFill>
+          <a:blip r:embed="rId2"/>
+          <a:stretch>
+            <a:fillRect/>
+          </a:stretch>
+        </p:blipFill>
+        <p:spPr>
+          <a:xfrm>
+            <a:off x="721418" y="1371600"/>
+            <a:ext cx="331099" cy="603504"/>
           </a:xfrm>
           <a:prstGeom prst="rect">
             <a:avLst/>
           </a:prstGeom>
+        </p:spPr>
+      </p:pic>
+      <p:sp>
+        <p:nvSpPr>
+          <p:cNvPr id="8" name="TextBox 7"/>
+          <p:cNvSpPr txBox="1"/>
+          <p:nvPr/>
+        </p:nvSpPr>
+        <p:spPr>
+          <a:xfrm>
+            <a:off x="1316736" y="1371600"/>
+            <a:ext cx="3017520" cy="548640"/>
+          </a:xfrm>
+          <a:prstGeom prst="rect">
+            <a:avLst/>
+          </a:prstGeom>
           <a:noFill/>
         </p:spPr>
         <p:txBody>
-          <a:bodyPr wrap="square" anchor="t" lIns="54864" rIns="54864" tIns="27432" bIns="27432">
+          <a:bodyPr wrap="square" anchor="ctr" lIns="54864" rIns="54864" tIns="27432" bIns="27432">
             <a:spAutoFit/>
           </a:bodyPr>
           <a:lstStyle/>
           <a:p>
-            <a:pPr algn="l"/>
+            <a:pPr algn="l">
+              <a:lnSpc>
+                <a:spcPct val="100000"/>
+              </a:lnSpc>
+            </a:pPr>
             <a:r>
               <a:rPr sz="1350" b="1" i="0">
                 <a:solidFill>
@@ -10811,14 +10374,14 @@
       </p:sp>
       <p:sp>
         <p:nvSpPr>
-          <p:cNvPr id="8" name="Rectangle 7"/>
+          <p:cNvPr id="9" name="Rectangle 8"/>
           <p:cNvSpPr/>
           <p:nvPr/>
         </p:nvSpPr>
         <p:spPr>
           <a:xfrm>
-            <a:off x="612647" y="1682496"/>
-            <a:ext cx="1005840" cy="32004"/>
+            <a:off x="1316736" y="1938528"/>
+            <a:ext cx="914400" cy="27432"/>
           </a:xfrm>
           <a:prstGeom prst="rect">
             <a:avLst/>
@@ -10855,14 +10418,14 @@
       </p:sp>
       <p:sp>
         <p:nvSpPr>
-          <p:cNvPr id="9" name="TextBox 8"/>
+          <p:cNvPr id="10" name="TextBox 9"/>
           <p:cNvSpPr txBox="1"/>
           <p:nvPr/>
         </p:nvSpPr>
         <p:spPr>
           <a:xfrm>
-            <a:off x="612647" y="1792224"/>
-            <a:ext cx="3712463" cy="768096"/>
+            <a:off x="612647" y="2029968"/>
+            <a:ext cx="3712463" cy="585216"/>
           </a:xfrm>
           <a:prstGeom prst="rect">
             <a:avLst/>
@@ -10879,9 +10442,6 @@
               <a:lnSpc>
                 <a:spcPct val="105000"/>
               </a:lnSpc>
-              <a:spcAft>
-                <a:spcPts val="400"/>
-              </a:spcAft>
             </a:pPr>
             <a:r>
               <a:rPr sz="1150" b="0" i="0">
@@ -10897,7 +10457,7 @@
       </p:sp>
       <p:sp>
         <p:nvSpPr>
-          <p:cNvPr id="10" name="Rounded Rectangle 9"/>
+          <p:cNvPr id="11" name="Rounded Rectangle 10"/>
           <p:cNvSpPr/>
           <p:nvPr/>
         </p:nvSpPr>
@@ -10943,29 +10503,57 @@
           </a:p>
         </p:txBody>
       </p:sp>
-      <p:sp>
-        <p:nvSpPr>
-          <p:cNvPr id="11" name="TextBox 10"/>
-          <p:cNvSpPr txBox="1"/>
-          <p:nvPr/>
-        </p:nvSpPr>
-        <p:spPr>
-          <a:xfrm>
-            <a:off x="4828032" y="1344168"/>
-            <a:ext cx="3712463" cy="274320"/>
+      <p:pic>
+        <p:nvPicPr>
+          <p:cNvPr id="12" name="Picture 11" descr="image.png"/>
+          <p:cNvPicPr>
+            <a:picLocks noChangeAspect="1"/>
+          </p:cNvPicPr>
+          <p:nvPr/>
+        </p:nvPicPr>
+        <p:blipFill>
+          <a:blip r:embed="rId3"/>
+          <a:stretch>
+            <a:fillRect/>
+          </a:stretch>
+        </p:blipFill>
+        <p:spPr>
+          <a:xfrm>
+            <a:off x="4800600" y="1376213"/>
+            <a:ext cx="603504" cy="594276"/>
           </a:xfrm>
           <a:prstGeom prst="rect">
             <a:avLst/>
           </a:prstGeom>
+        </p:spPr>
+      </p:pic>
+      <p:sp>
+        <p:nvSpPr>
+          <p:cNvPr id="13" name="TextBox 12"/>
+          <p:cNvSpPr txBox="1"/>
+          <p:nvPr/>
+        </p:nvSpPr>
+        <p:spPr>
+          <a:xfrm>
+            <a:off x="5532120" y="1371600"/>
+            <a:ext cx="3017520" cy="548640"/>
+          </a:xfrm>
+          <a:prstGeom prst="rect">
+            <a:avLst/>
+          </a:prstGeom>
           <a:noFill/>
         </p:spPr>
         <p:txBody>
-          <a:bodyPr wrap="square" anchor="t" lIns="54864" rIns="54864" tIns="27432" bIns="27432">
+          <a:bodyPr wrap="square" anchor="ctr" lIns="54864" rIns="54864" tIns="27432" bIns="27432">
             <a:spAutoFit/>
           </a:bodyPr>
           <a:lstStyle/>
           <a:p>
-            <a:pPr algn="l"/>
+            <a:pPr algn="l">
+              <a:lnSpc>
+                <a:spcPct val="100000"/>
+              </a:lnSpc>
+            </a:pPr>
             <a:r>
               <a:rPr sz="1350" b="1" i="0">
                 <a:solidFill>
@@ -10980,14 +10568,14 @@
       </p:sp>
       <p:sp>
         <p:nvSpPr>
-          <p:cNvPr id="12" name="Rectangle 11"/>
+          <p:cNvPr id="14" name="Rectangle 13"/>
           <p:cNvSpPr/>
           <p:nvPr/>
         </p:nvSpPr>
         <p:spPr>
           <a:xfrm>
-            <a:off x="4828032" y="1682496"/>
-            <a:ext cx="1005840" cy="32004"/>
+            <a:off x="5532120" y="1938528"/>
+            <a:ext cx="914400" cy="27432"/>
           </a:xfrm>
           <a:prstGeom prst="rect">
             <a:avLst/>
@@ -11024,14 +10612,14 @@
       </p:sp>
       <p:sp>
         <p:nvSpPr>
-          <p:cNvPr id="13" name="TextBox 12"/>
+          <p:cNvPr id="15" name="TextBox 14"/>
           <p:cNvSpPr txBox="1"/>
           <p:nvPr/>
         </p:nvSpPr>
         <p:spPr>
           <a:xfrm>
-            <a:off x="4828032" y="1792224"/>
-            <a:ext cx="3712463" cy="768096"/>
+            <a:off x="4828032" y="2029968"/>
+            <a:ext cx="3712463" cy="585216"/>
           </a:xfrm>
           <a:prstGeom prst="rect">
             <a:avLst/>
@@ -11048,9 +10636,6 @@
               <a:lnSpc>
                 <a:spcPct val="105000"/>
               </a:lnSpc>
-              <a:spcAft>
-                <a:spcPts val="400"/>
-              </a:spcAft>
             </a:pPr>
             <a:r>
               <a:rPr sz="1150" b="0" i="0">
@@ -11066,7 +10651,7 @@
       </p:sp>
       <p:sp>
         <p:nvSpPr>
-          <p:cNvPr id="14" name="Rounded Rectangle 13"/>
+          <p:cNvPr id="16" name="Rounded Rectangle 15"/>
           <p:cNvSpPr/>
           <p:nvPr/>
         </p:nvSpPr>
@@ -11112,29 +10697,57 @@
           </a:p>
         </p:txBody>
       </p:sp>
-      <p:sp>
-        <p:nvSpPr>
-          <p:cNvPr id="15" name="TextBox 14"/>
-          <p:cNvSpPr txBox="1"/>
-          <p:nvPr/>
-        </p:nvSpPr>
-        <p:spPr>
-          <a:xfrm>
-            <a:off x="612647" y="2971800"/>
-            <a:ext cx="3712463" cy="274320"/>
+      <p:pic>
+        <p:nvPicPr>
+          <p:cNvPr id="17" name="Picture 16" descr="image.png"/>
+          <p:cNvPicPr>
+            <a:picLocks noChangeAspect="1"/>
+          </p:cNvPicPr>
+          <p:nvPr/>
+        </p:nvPicPr>
+        <p:blipFill>
+          <a:blip r:embed="rId4"/>
+          <a:stretch>
+            <a:fillRect/>
+          </a:stretch>
+        </p:blipFill>
+        <p:spPr>
+          <a:xfrm>
+            <a:off x="585216" y="3066375"/>
+            <a:ext cx="603504" cy="469216"/>
           </a:xfrm>
           <a:prstGeom prst="rect">
             <a:avLst/>
           </a:prstGeom>
+        </p:spPr>
+      </p:pic>
+      <p:sp>
+        <p:nvSpPr>
+          <p:cNvPr id="18" name="TextBox 17"/>
+          <p:cNvSpPr txBox="1"/>
+          <p:nvPr/>
+        </p:nvSpPr>
+        <p:spPr>
+          <a:xfrm>
+            <a:off x="1316736" y="2999232"/>
+            <a:ext cx="3017520" cy="548640"/>
+          </a:xfrm>
+          <a:prstGeom prst="rect">
+            <a:avLst/>
+          </a:prstGeom>
           <a:noFill/>
         </p:spPr>
         <p:txBody>
-          <a:bodyPr wrap="square" anchor="t" lIns="54864" rIns="54864" tIns="27432" bIns="27432">
+          <a:bodyPr wrap="square" anchor="ctr" lIns="54864" rIns="54864" tIns="27432" bIns="27432">
             <a:spAutoFit/>
           </a:bodyPr>
           <a:lstStyle/>
           <a:p>
-            <a:pPr algn="l"/>
+            <a:pPr algn="l">
+              <a:lnSpc>
+                <a:spcPct val="100000"/>
+              </a:lnSpc>
+            </a:pPr>
             <a:r>
               <a:rPr sz="1350" b="1" i="0">
                 <a:solidFill>
@@ -11149,14 +10762,14 @@
       </p:sp>
       <p:sp>
         <p:nvSpPr>
-          <p:cNvPr id="16" name="Rectangle 15"/>
+          <p:cNvPr id="19" name="Rectangle 18"/>
           <p:cNvSpPr/>
           <p:nvPr/>
         </p:nvSpPr>
         <p:spPr>
           <a:xfrm>
-            <a:off x="612647" y="3310128"/>
-            <a:ext cx="1005840" cy="32004"/>
+            <a:off x="1316736" y="3566160"/>
+            <a:ext cx="914400" cy="27432"/>
           </a:xfrm>
           <a:prstGeom prst="rect">
             <a:avLst/>
@@ -11193,14 +10806,14 @@
       </p:sp>
       <p:sp>
         <p:nvSpPr>
-          <p:cNvPr id="17" name="TextBox 16"/>
+          <p:cNvPr id="20" name="TextBox 19"/>
           <p:cNvSpPr txBox="1"/>
           <p:nvPr/>
         </p:nvSpPr>
         <p:spPr>
           <a:xfrm>
-            <a:off x="612647" y="3419856"/>
-            <a:ext cx="3712463" cy="768096"/>
+            <a:off x="612647" y="3657600"/>
+            <a:ext cx="3712463" cy="585216"/>
           </a:xfrm>
           <a:prstGeom prst="rect">
             <a:avLst/>
@@ -11217,9 +10830,6 @@
               <a:lnSpc>
                 <a:spcPct val="105000"/>
               </a:lnSpc>
-              <a:spcAft>
-                <a:spcPts val="400"/>
-              </a:spcAft>
             </a:pPr>
             <a:r>
               <a:rPr sz="1150" b="0" i="0">
@@ -11235,7 +10845,7 @@
       </p:sp>
       <p:sp>
         <p:nvSpPr>
-          <p:cNvPr id="18" name="Rounded Rectangle 17"/>
+          <p:cNvPr id="21" name="Rounded Rectangle 20"/>
           <p:cNvSpPr/>
           <p:nvPr/>
         </p:nvSpPr>
@@ -11281,29 +10891,57 @@
           </a:p>
         </p:txBody>
       </p:sp>
-      <p:sp>
-        <p:nvSpPr>
-          <p:cNvPr id="19" name="TextBox 18"/>
-          <p:cNvSpPr txBox="1"/>
-          <p:nvPr/>
-        </p:nvSpPr>
-        <p:spPr>
-          <a:xfrm>
-            <a:off x="4828032" y="2971800"/>
-            <a:ext cx="3712463" cy="274320"/>
+      <p:pic>
+        <p:nvPicPr>
+          <p:cNvPr id="22" name="Picture 21" descr="image.png"/>
+          <p:cNvPicPr>
+            <a:picLocks noChangeAspect="1"/>
+          </p:cNvPicPr>
+          <p:nvPr/>
+        </p:nvPicPr>
+        <p:blipFill>
+          <a:blip r:embed="rId5"/>
+          <a:stretch>
+            <a:fillRect/>
+          </a:stretch>
+        </p:blipFill>
+        <p:spPr>
+          <a:xfrm>
+            <a:off x="4800600" y="3023951"/>
+            <a:ext cx="603504" cy="554064"/>
           </a:xfrm>
           <a:prstGeom prst="rect">
             <a:avLst/>
           </a:prstGeom>
+        </p:spPr>
+      </p:pic>
+      <p:sp>
+        <p:nvSpPr>
+          <p:cNvPr id="23" name="TextBox 22"/>
+          <p:cNvSpPr txBox="1"/>
+          <p:nvPr/>
+        </p:nvSpPr>
+        <p:spPr>
+          <a:xfrm>
+            <a:off x="5532120" y="2999232"/>
+            <a:ext cx="3017520" cy="548640"/>
+          </a:xfrm>
+          <a:prstGeom prst="rect">
+            <a:avLst/>
+          </a:prstGeom>
           <a:noFill/>
         </p:spPr>
         <p:txBody>
-          <a:bodyPr wrap="square" anchor="t" lIns="54864" rIns="54864" tIns="27432" bIns="27432">
+          <a:bodyPr wrap="square" anchor="ctr" lIns="54864" rIns="54864" tIns="27432" bIns="27432">
             <a:spAutoFit/>
           </a:bodyPr>
           <a:lstStyle/>
           <a:p>
-            <a:pPr algn="l"/>
+            <a:pPr algn="l">
+              <a:lnSpc>
+                <a:spcPct val="100000"/>
+              </a:lnSpc>
+            </a:pPr>
             <a:r>
               <a:rPr sz="1350" b="1" i="0">
                 <a:solidFill>
@@ -11318,14 +10956,14 @@
       </p:sp>
       <p:sp>
         <p:nvSpPr>
-          <p:cNvPr id="20" name="Rectangle 19"/>
+          <p:cNvPr id="24" name="Rectangle 23"/>
           <p:cNvSpPr/>
           <p:nvPr/>
         </p:nvSpPr>
         <p:spPr>
           <a:xfrm>
-            <a:off x="4828032" y="3310128"/>
-            <a:ext cx="1005840" cy="32004"/>
+            <a:off x="5532120" y="3566160"/>
+            <a:ext cx="914400" cy="27432"/>
           </a:xfrm>
           <a:prstGeom prst="rect">
             <a:avLst/>
@@ -11362,14 +11000,14 @@
       </p:sp>
       <p:sp>
         <p:nvSpPr>
-          <p:cNvPr id="21" name="TextBox 20"/>
+          <p:cNvPr id="25" name="TextBox 24"/>
           <p:cNvSpPr txBox="1"/>
           <p:nvPr/>
         </p:nvSpPr>
         <p:spPr>
           <a:xfrm>
-            <a:off x="4828032" y="3419856"/>
-            <a:ext cx="3712463" cy="768096"/>
+            <a:off x="4828032" y="3657600"/>
+            <a:ext cx="3712463" cy="585216"/>
           </a:xfrm>
           <a:prstGeom prst="rect">
             <a:avLst/>
@@ -11386,9 +11024,6 @@
               <a:lnSpc>
                 <a:spcPct val="105000"/>
               </a:lnSpc>
-              <a:spcAft>
-                <a:spcPts val="400"/>
-              </a:spcAft>
             </a:pPr>
             <a:r>
               <a:rPr sz="1150" b="0" i="0">
@@ -11404,7 +11039,7 @@
       </p:sp>
       <p:sp>
         <p:nvSpPr>
-          <p:cNvPr id="22" name="Rectangle 21"/>
+          <p:cNvPr id="26" name="Rectangle 25"/>
           <p:cNvSpPr/>
           <p:nvPr/>
         </p:nvSpPr>
@@ -11448,7 +11083,7 @@
       </p:sp>
       <p:sp>
         <p:nvSpPr>
-          <p:cNvPr id="23" name="TextBox 22"/>
+          <p:cNvPr id="27" name="TextBox 26"/>
           <p:cNvSpPr txBox="1"/>
           <p:nvPr/>
         </p:nvSpPr>
@@ -11483,7 +11118,7 @@
       </p:sp>
       <p:sp>
         <p:nvSpPr>
-          <p:cNvPr id="24" name="TextBox 23"/>
+          <p:cNvPr id="28" name="TextBox 27"/>
           <p:cNvSpPr txBox="1"/>
           <p:nvPr/>
         </p:nvSpPr>
@@ -12406,8 +12041,8 @@
           <p:nvPr/>
         </p:nvGraphicFramePr>
         <p:xfrm>
-          <a:off x="448056" y="2011680"/>
-          <a:ext cx="8257032" cy="2148840"/>
+          <a:off x="448056" y="1993392"/>
+          <a:ext cx="5623560" cy="2194560"/>
         </p:xfrm>
         <a:graphic>
           <a:graphicData uri="http://schemas.openxmlformats.org/drawingml/2006/table">
@@ -12416,18 +12051,18 @@
                 <a:tableStyleId>{5C22544A-7EE6-4342-B048-85BDC9FD1C3A}</a:tableStyleId>
               </a:tblPr>
               <a:tblGrid>
-                <a:gridCol w="2240280"/>
-                <a:gridCol w="2788920"/>
-                <a:gridCol w="3227832"/>
+                <a:gridCol w="1371600"/>
+                <a:gridCol w="1737360"/>
+                <a:gridCol w="2514600"/>
               </a:tblGrid>
-              <a:tr h="429768">
+              <a:tr h="438912">
                 <a:tc>
                   <a:txBody>
                     <a:bodyPr wrap="square"/>
                     <a:lstStyle/>
                     <a:p>
                       <a:r>
-                        <a:rPr sz="1200" b="1">
+                        <a:rPr sz="1100" b="1">
                           <a:solidFill>
                             <a:srgbClr val="FFFFFF"/>
                           </a:solidFill>
@@ -12449,7 +12084,7 @@
                     <a:lstStyle/>
                     <a:p>
                       <a:r>
-                        <a:rPr sz="1200" b="1">
+                        <a:rPr sz="1100" b="1">
                           <a:solidFill>
                             <a:srgbClr val="FFFFFF"/>
                           </a:solidFill>
@@ -12471,7 +12106,7 @@
                     <a:lstStyle/>
                     <a:p>
                       <a:r>
-                        <a:rPr sz="1200" b="1">
+                        <a:rPr sz="1100" b="1">
                           <a:solidFill>
                             <a:srgbClr val="FFFFFF"/>
                           </a:solidFill>
@@ -12488,14 +12123,14 @@
                   </a:tcPr>
                 </a:tc>
               </a:tr>
-              <a:tr h="429768">
+              <a:tr h="438912">
                 <a:tc>
                   <a:txBody>
                     <a:bodyPr wrap="square"/>
                     <a:lstStyle/>
                     <a:p>
                       <a:r>
-                        <a:rPr sz="1100" b="1">
+                        <a:rPr sz="1000" b="1">
                           <a:solidFill>
                             <a:srgbClr val="01499B"/>
                           </a:solidFill>
@@ -12517,7 +12152,7 @@
                     <a:lstStyle/>
                     <a:p>
                       <a:r>
-                        <a:rPr sz="1100" b="0">
+                        <a:rPr sz="1000" b="0">
                           <a:solidFill>
                             <a:srgbClr val="374151"/>
                           </a:solidFill>
@@ -12539,7 +12174,7 @@
                     <a:lstStyle/>
                     <a:p>
                       <a:r>
-                        <a:rPr sz="1100" b="0">
+                        <a:rPr sz="1000" b="0">
                           <a:solidFill>
                             <a:srgbClr val="374151"/>
                           </a:solidFill>
@@ -12556,14 +12191,14 @@
                   </a:tcPr>
                 </a:tc>
               </a:tr>
-              <a:tr h="429768">
+              <a:tr h="438912">
                 <a:tc>
                   <a:txBody>
                     <a:bodyPr wrap="square"/>
                     <a:lstStyle/>
                     <a:p>
                       <a:r>
-                        <a:rPr sz="1100" b="1">
+                        <a:rPr sz="1000" b="1">
                           <a:solidFill>
                             <a:srgbClr val="01499B"/>
                           </a:solidFill>
@@ -12585,7 +12220,7 @@
                     <a:lstStyle/>
                     <a:p>
                       <a:r>
-                        <a:rPr sz="1100" b="0">
+                        <a:rPr sz="1000" b="0">
                           <a:solidFill>
                             <a:srgbClr val="374151"/>
                           </a:solidFill>
@@ -12607,7 +12242,7 @@
                     <a:lstStyle/>
                     <a:p>
                       <a:r>
-                        <a:rPr sz="1100" b="0">
+                        <a:rPr sz="1000" b="0">
                           <a:solidFill>
                             <a:srgbClr val="374151"/>
                           </a:solidFill>
@@ -12624,14 +12259,14 @@
                   </a:tcPr>
                 </a:tc>
               </a:tr>
-              <a:tr h="429768">
+              <a:tr h="438912">
                 <a:tc>
                   <a:txBody>
                     <a:bodyPr wrap="square"/>
                     <a:lstStyle/>
                     <a:p>
                       <a:r>
-                        <a:rPr sz="1100" b="1">
+                        <a:rPr sz="1000" b="1">
                           <a:solidFill>
                             <a:srgbClr val="01499B"/>
                           </a:solidFill>
@@ -12653,7 +12288,7 @@
                     <a:lstStyle/>
                     <a:p>
                       <a:r>
-                        <a:rPr sz="1100" b="0">
+                        <a:rPr sz="1000" b="0">
                           <a:solidFill>
                             <a:srgbClr val="374151"/>
                           </a:solidFill>
@@ -12675,7 +12310,7 @@
                     <a:lstStyle/>
                     <a:p>
                       <a:r>
-                        <a:rPr sz="1100" b="0">
+                        <a:rPr sz="1000" b="0">
                           <a:solidFill>
                             <a:srgbClr val="374151"/>
                           </a:solidFill>
@@ -12692,14 +12327,14 @@
                   </a:tcPr>
                 </a:tc>
               </a:tr>
-              <a:tr h="429768">
+              <a:tr h="438912">
                 <a:tc>
                   <a:txBody>
                     <a:bodyPr wrap="square"/>
                     <a:lstStyle/>
                     <a:p>
                       <a:r>
-                        <a:rPr sz="1100" b="1">
+                        <a:rPr sz="1000" b="1">
                           <a:solidFill>
                             <a:srgbClr val="01499B"/>
                           </a:solidFill>
@@ -12721,7 +12356,7 @@
                     <a:lstStyle/>
                     <a:p>
                       <a:r>
-                        <a:rPr sz="1100" b="0">
+                        <a:rPr sz="1000" b="0">
                           <a:solidFill>
                             <a:srgbClr val="374151"/>
                           </a:solidFill>
@@ -12743,7 +12378,7 @@
                     <a:lstStyle/>
                     <a:p>
                       <a:r>
-                        <a:rPr sz="1100" b="0">
+                        <a:rPr sz="1000" b="0">
                           <a:solidFill>
                             <a:srgbClr val="374151"/>
                           </a:solidFill>
@@ -12764,9 +12399,33 @@
           </a:graphicData>
         </a:graphic>
       </p:graphicFrame>
-      <p:sp>
-        <p:nvSpPr>
-          <p:cNvPr id="9" name="Rounded Rectangle 8"/>
+      <p:pic>
+        <p:nvPicPr>
+          <p:cNvPr id="9" name="Picture 8" descr="image.png"/>
+          <p:cNvPicPr>
+            <a:picLocks noChangeAspect="1"/>
+          </p:cNvPicPr>
+          <p:nvPr/>
+        </p:nvPicPr>
+        <p:blipFill>
+          <a:blip r:embed="rId2"/>
+          <a:stretch>
+            <a:fillRect/>
+          </a:stretch>
+        </p:blipFill>
+        <p:spPr>
+          <a:xfrm>
+            <a:off x="6199632" y="2295408"/>
+            <a:ext cx="2505456" cy="1572239"/>
+          </a:xfrm>
+          <a:prstGeom prst="rect">
+            <a:avLst/>
+          </a:prstGeom>
+        </p:spPr>
+      </p:pic>
+      <p:sp>
+        <p:nvSpPr>
+          <p:cNvPr id="10" name="Rounded Rectangle 9"/>
           <p:cNvSpPr/>
           <p:nvPr/>
         </p:nvSpPr>
@@ -12830,7 +12489,7 @@
       </p:sp>
       <p:sp>
         <p:nvSpPr>
-          <p:cNvPr id="10" name="Rectangle 9"/>
+          <p:cNvPr id="11" name="Rectangle 10"/>
           <p:cNvSpPr/>
           <p:nvPr/>
         </p:nvSpPr>
@@ -12874,7 +12533,7 @@
       </p:sp>
       <p:sp>
         <p:nvSpPr>
-          <p:cNvPr id="11" name="TextBox 10"/>
+          <p:cNvPr id="12" name="TextBox 11"/>
           <p:cNvSpPr txBox="1"/>
           <p:nvPr/>
         </p:nvSpPr>
@@ -12909,7 +12568,7 @@
       </p:sp>
       <p:sp>
         <p:nvSpPr>
-          <p:cNvPr id="12" name="TextBox 11"/>
+          <p:cNvPr id="13" name="TextBox 12"/>
           <p:cNvSpPr txBox="1"/>
           <p:nvPr/>
         </p:nvSpPr>

</xml_diff>